<commit_message>
Repo solo para estudiantes: elimina material docente (instrucciones-docente, demos, CLAUDE.md) y andamiaje generado; quita 'AI Chips' y quizzes; README por carpeta; Nano Banana como recurso del playground; programa sincronizado con el docx; PDFs y slides regenerados
</commit_message>
<xml_diff>
--- a/slides/sesion-01.pptx
+++ b/slides/sesion-01.pptx
@@ -9068,7 +9068,7 @@
                 </a:solidFill>
                 <a:latin typeface="Calibri"/>
               </a:rPr>
-              <a:t>•  Cloud Run para publicar · AI Chips (Nano Banana)</a:t>
+              <a:t>•  Cloud Run para publicar · Nano Banana para imágenes (playground)</a:t>
             </a:r>
           </a:p>
           <a:p>
@@ -11488,7 +11488,7 @@
                 </a:solidFill>
                 <a:latin typeface="Calibri"/>
               </a:rPr>
-              <a:t>AI Chips (Nano Banana)</a:t>
+              <a:t>Nano Banana (playground)</a:t>
             </a:r>
           </a:p>
           <a:p>
@@ -11504,7 +11504,7 @@
                 </a:solidFill>
                 <a:latin typeface="Calibri"/>
               </a:rPr>
-              <a:t>Servicios de Google dentro de AI Studio; Nano Banana genera imágenes.</a:t>
+              <a:t>Modelo de imágenes de Google; se usa en el playground de AI Studio, aparte de Build.</a:t>
             </a:r>
           </a:p>
         </p:txBody>

</xml_diff>